<commit_message>
feat: add 'From POC to Production Rollout' slide before Q&A
Insert new slide 8 (9 total) with three production roadmap milestones:
Sweep & Scale, Multi-Agent Guardrails, and Engineering Partnership.
Both HTML and PPTX versions updated and renumbered.

Co-Authored-By: Devin AI <158243242+devin-ai-integration[bot]@users.noreply.github.com>
</commit_message>
<xml_diff>
--- a/presentation.pptx
+++ b/presentation.pptx
@@ -12,6 +12,7 @@
     <p:sldId id="260" r:id="rId11"/>
     <p:sldId id="261" r:id="rId12"/>
     <p:sldId id="262" r:id="rId13"/>
+    <p:sldId id="264" r:id="rId15"/>
     <p:sldId id="263" r:id="rId14"/>
   </p:sldIdLst>
   <p:sldSz cx="12191695" cy="6858000" type="screen4x3"/>
@@ -3286,7 +3287,7 @@
               </a:defRPr>
             </a:pPr>
             <a:r>
-              <a:t>01 / 08</a:t>
+              <a:t>01 / 09</a:t>
             </a:r>
           </a:p>
         </p:txBody>
@@ -3998,7 +3999,7 @@
               </a:defRPr>
             </a:pPr>
             <a:r>
-              <a:t>02 / 08</a:t>
+              <a:t>02 / 09</a:t>
             </a:r>
           </a:p>
         </p:txBody>
@@ -4859,7 +4860,7 @@
               </a:defRPr>
             </a:pPr>
             <a:r>
-              <a:t>03 / 08</a:t>
+              <a:t>03 / 09</a:t>
             </a:r>
           </a:p>
         </p:txBody>
@@ -6323,7 +6324,7 @@
               </a:defRPr>
             </a:pPr>
             <a:r>
-              <a:t>04 / 08</a:t>
+              <a:t>04 / 09</a:t>
             </a:r>
           </a:p>
         </p:txBody>
@@ -6779,7 +6780,7 @@
               </a:defRPr>
             </a:pPr>
             <a:r>
-              <a:t>24/7</a:t>
+              <a:t>05 / 09</a:t>
             </a:r>
           </a:p>
         </p:txBody>
@@ -7346,7 +7347,7 @@
               </a:defRPr>
             </a:pPr>
             <a:r>
-              <a:t>05 / 08</a:t>
+              <a:t>05 / 09</a:t>
             </a:r>
           </a:p>
         </p:txBody>
@@ -8425,7 +8426,7 @@
               </a:defRPr>
             </a:pPr>
             <a:r>
-              <a:t>06 / 08</a:t>
+              <a:t>06 / 09</a:t>
             </a:r>
           </a:p>
         </p:txBody>
@@ -9100,7 +9101,7 @@
               </a:defRPr>
             </a:pPr>
             <a:r>
-              <a:t>07 / 08</a:t>
+              <a:t>07 / 09</a:t>
             </a:r>
           </a:p>
         </p:txBody>
@@ -9310,7 +9311,715 @@
               </a:defRPr>
             </a:pPr>
             <a:r>
-              <a:t>08 / 08</a:t>
+              <a:t>09 / 09</a:t>
+            </a:r>
+          </a:p>
+        </p:txBody>
+      </p:sp>
+    </p:spTree>
+  </p:cSld>
+  <p:clrMapOvr>
+    <a:masterClrMapping/>
+  </p:clrMapOvr>
+</p:sld>
+</file>
+
+<file path=ppt/slides/slide9.xml><?xml version="1.0" encoding="utf-8"?>
+<p:sld xmlns:a="http://schemas.openxmlformats.org/drawingml/2006/main" xmlns:p="http://schemas.openxmlformats.org/presentationml/2006/main" xmlns:r="http://schemas.openxmlformats.org/officeDocument/2006/relationships">
+  <p:cSld>
+    <p:bg>
+      <p:bgPr>
+        <a:solidFill>
+          <a:srgbClr val="0A0A0F"/>
+        </a:solidFill>
+        <a:effectLst/>
+      </p:bgPr>
+    </p:bg>
+    <p:spTree>
+      <p:nvGrpSpPr>
+        <p:cNvPr id="1" name=""/>
+        <p:cNvGrpSpPr/>
+        <p:nvPr/>
+      </p:nvGrpSpPr>
+      <p:grpSpPr/>
+      <p:sp>
+        <p:nvSpPr>
+          <p:cNvPr id="2" name="TextBox 1"/>
+          <p:cNvSpPr txBox="1"/>
+          <p:nvPr/>
+        </p:nvSpPr>
+        <p:spPr>
+          <a:xfrm>
+            <a:off x="1097280" y="731520"/>
+            <a:ext cx="3657600" cy="320040"/>
+          </a:xfrm>
+          <a:prstGeom prst="rect">
+            <a:avLst/>
+          </a:prstGeom>
+          <a:noFill/>
+        </p:spPr>
+        <p:txBody>
+          <a:bodyPr wrap="square">
+            <a:spAutoFit/>
+          </a:bodyPr>
+          <a:lstStyle/>
+          <a:p>
+            <a:pPr algn="l">
+              <a:defRPr sz="900" b="1">
+                <a:solidFill>
+                  <a:srgbClr val="818CF8"/>
+                </a:solidFill>
+                <a:latin typeface="Calibri"/>
+              </a:defRPr>
+            </a:pPr>
+            <a:r>
+              <a:t>THE ROADMAP</a:t>
+            </a:r>
+          </a:p>
+        </p:txBody>
+      </p:sp>
+      <p:sp>
+        <p:nvSpPr>
+          <p:cNvPr id="3" name="TextBox 2"/>
+          <p:cNvSpPr txBox="1"/>
+          <p:nvPr/>
+        </p:nvSpPr>
+        <p:spPr>
+          <a:xfrm>
+            <a:off x="1097280" y="1097280"/>
+            <a:ext cx="7315200" cy="640080"/>
+          </a:xfrm>
+          <a:prstGeom prst="rect">
+            <a:avLst/>
+          </a:prstGeom>
+          <a:noFill/>
+        </p:spPr>
+        <p:txBody>
+          <a:bodyPr wrap="square">
+            <a:spAutoFit/>
+          </a:bodyPr>
+          <a:lstStyle/>
+          <a:p>
+            <a:pPr algn="l">
+              <a:defRPr sz="3400" b="1">
+                <a:solidFill>
+                  <a:srgbClr val="F0F0F5"/>
+                </a:solidFill>
+                <a:latin typeface="Calibri"/>
+              </a:defRPr>
+            </a:pPr>
+            <a:r>
+              <a:t>From POC to Production Rollout</a:t>
+            </a:r>
+          </a:p>
+        </p:txBody>
+      </p:sp>
+      <p:sp>
+        <p:nvSpPr>
+          <p:cNvPr id="4" name="Rectangle 3"/>
+          <p:cNvSpPr/>
+          <p:nvPr/>
+        </p:nvSpPr>
+        <p:spPr>
+          <a:xfrm>
+            <a:off x="1097280" y="1783080"/>
+            <a:ext cx="457200" cy="38100"/>
+          </a:xfrm>
+          <a:prstGeom prst="rect">
+            <a:avLst/>
+          </a:prstGeom>
+          <a:solidFill>
+            <a:srgbClr val="6366F1"/>
+          </a:solidFill>
+          <a:ln>
+            <a:noFill/>
+          </a:ln>
+        </p:spPr>
+        <p:style>
+          <a:lnRef idx="1">
+            <a:schemeClr val="accent1"/>
+          </a:lnRef>
+          <a:fillRef idx="3">
+            <a:schemeClr val="accent1"/>
+          </a:fillRef>
+          <a:effectRef idx="2">
+            <a:schemeClr val="accent1"/>
+          </a:effectRef>
+          <a:fontRef idx="minor">
+            <a:schemeClr val="lt1"/>
+          </a:fontRef>
+        </p:style>
+        <p:txBody>
+          <a:bodyPr rtlCol="0" anchor="ctr"/>
+          <a:lstStyle/>
+          <a:p>
+            <a:pPr algn="ctr"/>
+          </a:p>
+        </p:txBody>
+      </p:sp>
+      <p:sp>
+        <p:nvSpPr>
+          <p:cNvPr id="5" name="TextBox 4"/>
+          <p:cNvSpPr txBox="1"/>
+          <p:nvPr/>
+        </p:nvSpPr>
+        <p:spPr>
+          <a:xfrm>
+            <a:off x="1097280" y="2103120"/>
+            <a:ext cx="7772400" cy="822960"/>
+          </a:xfrm>
+          <a:prstGeom prst="rect">
+            <a:avLst/>
+          </a:prstGeom>
+          <a:noFill/>
+        </p:spPr>
+        <p:txBody>
+          <a:bodyPr wrap="square">
+            <a:spAutoFit/>
+          </a:bodyPr>
+          <a:lstStyle/>
+          <a:p>
+            <a:pPr algn="l">
+              <a:defRPr sz="1400" b="0">
+                <a:solidFill>
+                  <a:srgbClr val="9CA3AF"/>
+                </a:solidFill>
+                <a:latin typeface="Calibri"/>
+              </a:defRPr>
+            </a:pPr>
+            <a:r>
+              <a:t>Today is a successful proof of concept. Here is how we scale it into an always-on enterprise capability.</a:t>
+            </a:r>
+          </a:p>
+        </p:txBody>
+      </p:sp>
+      <p:sp>
+        <p:nvSpPr>
+          <p:cNvPr id="6" name="Rounded Rectangle 5"/>
+          <p:cNvSpPr/>
+          <p:nvPr/>
+        </p:nvSpPr>
+        <p:spPr>
+          <a:xfrm>
+            <a:off x="1097280" y="3383280"/>
+            <a:ext cx="3200400" cy="2103120"/>
+          </a:xfrm>
+          <a:prstGeom prst="roundRect">
+            <a:avLst/>
+          </a:prstGeom>
+          <a:solidFill>
+            <a:srgbClr val="16161F"/>
+          </a:solidFill>
+          <a:ln w="12700">
+            <a:solidFill>
+              <a:srgbClr val="2A2A35"/>
+            </a:solidFill>
+          </a:ln>
+        </p:spPr>
+        <p:style>
+          <a:lnRef idx="1">
+            <a:schemeClr val="accent1"/>
+          </a:lnRef>
+          <a:fillRef idx="3">
+            <a:schemeClr val="accent1"/>
+          </a:fillRef>
+          <a:effectRef idx="2">
+            <a:schemeClr val="accent1"/>
+          </a:effectRef>
+          <a:fontRef idx="minor">
+            <a:schemeClr val="lt1"/>
+          </a:fontRef>
+        </p:style>
+        <p:txBody>
+          <a:bodyPr rtlCol="0" anchor="ctr"/>
+          <a:lstStyle/>
+          <a:p>
+            <a:pPr algn="ctr"/>
+          </a:p>
+        </p:txBody>
+      </p:sp>
+      <p:sp>
+        <p:nvSpPr>
+          <p:cNvPr id="7" name="TextBox 6"/>
+          <p:cNvSpPr txBox="1"/>
+          <p:nvPr/>
+        </p:nvSpPr>
+        <p:spPr>
+          <a:xfrm>
+            <a:off x="1325880" y="3566160"/>
+            <a:ext cx="457200" cy="365760"/>
+          </a:xfrm>
+          <a:prstGeom prst="rect">
+            <a:avLst/>
+          </a:prstGeom>
+          <a:noFill/>
+        </p:spPr>
+        <p:txBody>
+          <a:bodyPr wrap="square">
+            <a:spAutoFit/>
+          </a:bodyPr>
+          <a:lstStyle/>
+          <a:p>
+            <a:pPr algn="l">
+              <a:defRPr sz="2000" b="0">
+                <a:solidFill>
+                  <a:srgbClr val="F0F0F5"/>
+                </a:solidFill>
+                <a:latin typeface="Calibri"/>
+              </a:defRPr>
+            </a:pPr>
+            <a:r>
+              <a:t>📈</a:t>
+            </a:r>
+          </a:p>
+        </p:txBody>
+      </p:sp>
+      <p:sp>
+        <p:nvSpPr>
+          <p:cNvPr id="8" name="TextBox 7"/>
+          <p:cNvSpPr txBox="1"/>
+          <p:nvPr/>
+        </p:nvSpPr>
+        <p:spPr>
+          <a:xfrm>
+            <a:off x="1325880" y="3886200"/>
+            <a:ext cx="2743200" cy="320040"/>
+          </a:xfrm>
+          <a:prstGeom prst="rect">
+            <a:avLst/>
+          </a:prstGeom>
+          <a:noFill/>
+        </p:spPr>
+        <p:txBody>
+          <a:bodyPr wrap="square">
+            <a:spAutoFit/>
+          </a:bodyPr>
+          <a:lstStyle/>
+          <a:p>
+            <a:pPr algn="l">
+              <a:defRPr sz="1300" b="1">
+                <a:solidFill>
+                  <a:srgbClr val="F0F0F5"/>
+                </a:solidFill>
+                <a:latin typeface="Calibri"/>
+              </a:defRPr>
+            </a:pPr>
+            <a:r>
+              <a:t>Sweep &amp; Scale</a:t>
+            </a:r>
+          </a:p>
+        </p:txBody>
+      </p:sp>
+      <p:sp>
+        <p:nvSpPr>
+          <p:cNvPr id="9" name="TextBox 8"/>
+          <p:cNvSpPr txBox="1"/>
+          <p:nvPr/>
+        </p:nvSpPr>
+        <p:spPr>
+          <a:xfrm>
+            <a:off x="1325880" y="4206240"/>
+            <a:ext cx="2743200" cy="1097280"/>
+          </a:xfrm>
+          <a:prstGeom prst="rect">
+            <a:avLst/>
+          </a:prstGeom>
+          <a:noFill/>
+        </p:spPr>
+        <p:txBody>
+          <a:bodyPr wrap="square">
+            <a:spAutoFit/>
+          </a:bodyPr>
+          <a:lstStyle/>
+          <a:p>
+            <a:pPr algn="l">
+              <a:defRPr sz="1000" b="0">
+                <a:solidFill>
+                  <a:srgbClr val="9CA3AF"/>
+                </a:solidFill>
+                <a:latin typeface="Calibri"/>
+              </a:defRPr>
+            </a:pPr>
+            <a:r>
+              <a:t>Connect Devin to more repositories and trigger automated backlog sweeps — continuously clearing existing security debt in the background.</a:t>
+            </a:r>
+          </a:p>
+        </p:txBody>
+      </p:sp>
+      <p:sp>
+        <p:nvSpPr>
+          <p:cNvPr id="10" name="Rounded Rectangle 9"/>
+          <p:cNvSpPr/>
+          <p:nvPr/>
+        </p:nvSpPr>
+        <p:spPr>
+          <a:xfrm>
+            <a:off x="4663440" y="3383280"/>
+            <a:ext cx="3200400" cy="2103120"/>
+          </a:xfrm>
+          <a:prstGeom prst="roundRect">
+            <a:avLst/>
+          </a:prstGeom>
+          <a:solidFill>
+            <a:srgbClr val="16161F"/>
+          </a:solidFill>
+          <a:ln w="12700">
+            <a:solidFill>
+              <a:srgbClr val="2A2A35"/>
+            </a:solidFill>
+          </a:ln>
+        </p:spPr>
+        <p:style>
+          <a:lnRef idx="1">
+            <a:schemeClr val="accent1"/>
+          </a:lnRef>
+          <a:fillRef idx="3">
+            <a:schemeClr val="accent1"/>
+          </a:fillRef>
+          <a:effectRef idx="2">
+            <a:schemeClr val="accent1"/>
+          </a:effectRef>
+          <a:fontRef idx="minor">
+            <a:schemeClr val="lt1"/>
+          </a:fontRef>
+        </p:style>
+        <p:txBody>
+          <a:bodyPr rtlCol="0" anchor="ctr"/>
+          <a:lstStyle/>
+          <a:p>
+            <a:pPr algn="ctr"/>
+          </a:p>
+        </p:txBody>
+      </p:sp>
+      <p:sp>
+        <p:nvSpPr>
+          <p:cNvPr id="11" name="TextBox 10"/>
+          <p:cNvSpPr txBox="1"/>
+          <p:nvPr/>
+        </p:nvSpPr>
+        <p:spPr>
+          <a:xfrm>
+            <a:off x="4892040" y="3566160"/>
+            <a:ext cx="457200" cy="365760"/>
+          </a:xfrm>
+          <a:prstGeom prst="rect">
+            <a:avLst/>
+          </a:prstGeom>
+          <a:noFill/>
+        </p:spPr>
+        <p:txBody>
+          <a:bodyPr wrap="square">
+            <a:spAutoFit/>
+          </a:bodyPr>
+          <a:lstStyle/>
+          <a:p>
+            <a:pPr algn="l">
+              <a:defRPr sz="2000" b="0">
+                <a:solidFill>
+                  <a:srgbClr val="F0F0F5"/>
+                </a:solidFill>
+                <a:latin typeface="Calibri"/>
+              </a:defRPr>
+            </a:pPr>
+            <a:r>
+              <a:t>🛡️</a:t>
+            </a:r>
+          </a:p>
+        </p:txBody>
+      </p:sp>
+      <p:sp>
+        <p:nvSpPr>
+          <p:cNvPr id="12" name="TextBox 11"/>
+          <p:cNvSpPr txBox="1"/>
+          <p:nvPr/>
+        </p:nvSpPr>
+        <p:spPr>
+          <a:xfrm>
+            <a:off x="4892040" y="3886200"/>
+            <a:ext cx="2743200" cy="320040"/>
+          </a:xfrm>
+          <a:prstGeom prst="rect">
+            <a:avLst/>
+          </a:prstGeom>
+          <a:noFill/>
+        </p:spPr>
+        <p:txBody>
+          <a:bodyPr wrap="square">
+            <a:spAutoFit/>
+          </a:bodyPr>
+          <a:lstStyle/>
+          <a:p>
+            <a:pPr algn="l">
+              <a:defRPr sz="1300" b="1">
+                <a:solidFill>
+                  <a:srgbClr val="F0F0F5"/>
+                </a:solidFill>
+                <a:latin typeface="Calibri"/>
+              </a:defRPr>
+            </a:pPr>
+            <a:r>
+              <a:t>Multi-Agent Guardrails</a:t>
+            </a:r>
+          </a:p>
+        </p:txBody>
+      </p:sp>
+      <p:sp>
+        <p:nvSpPr>
+          <p:cNvPr id="13" name="TextBox 12"/>
+          <p:cNvSpPr txBox="1"/>
+          <p:nvPr/>
+        </p:nvSpPr>
+        <p:spPr>
+          <a:xfrm>
+            <a:off x="4892040" y="4206240"/>
+            <a:ext cx="2743200" cy="1097280"/>
+          </a:xfrm>
+          <a:prstGeom prst="rect">
+            <a:avLst/>
+          </a:prstGeom>
+          <a:noFill/>
+        </p:spPr>
+        <p:txBody>
+          <a:bodyPr wrap="square">
+            <a:spAutoFit/>
+          </a:bodyPr>
+          <a:lstStyle/>
+          <a:p>
+            <a:pPr algn="l">
+              <a:defRPr sz="1000" b="0">
+                <a:solidFill>
+                  <a:srgbClr val="9CA3AF"/>
+                </a:solidFill>
+                <a:latin typeface="Calibri"/>
+              </a:defRPr>
+            </a:pPr>
+            <a:r>
+              <a:t>A second Devin instance acts as an automated peer-reviewer, auditing every patch before a human engineer ever sees it.</a:t>
+            </a:r>
+          </a:p>
+        </p:txBody>
+      </p:sp>
+      <p:sp>
+        <p:nvSpPr>
+          <p:cNvPr id="14" name="Rounded Rectangle 13"/>
+          <p:cNvSpPr/>
+          <p:nvPr/>
+        </p:nvSpPr>
+        <p:spPr>
+          <a:xfrm>
+            <a:off x="8229600" y="3383280"/>
+            <a:ext cx="3200400" cy="2103120"/>
+          </a:xfrm>
+          <a:prstGeom prst="roundRect">
+            <a:avLst/>
+          </a:prstGeom>
+          <a:solidFill>
+            <a:srgbClr val="16161F"/>
+          </a:solidFill>
+          <a:ln w="12700">
+            <a:solidFill>
+              <a:srgbClr val="2A2A35"/>
+            </a:solidFill>
+          </a:ln>
+        </p:spPr>
+        <p:style>
+          <a:lnRef idx="1">
+            <a:schemeClr val="accent1"/>
+          </a:lnRef>
+          <a:fillRef idx="3">
+            <a:schemeClr val="accent1"/>
+          </a:fillRef>
+          <a:effectRef idx="2">
+            <a:schemeClr val="accent1"/>
+          </a:effectRef>
+          <a:fontRef idx="minor">
+            <a:schemeClr val="lt1"/>
+          </a:fontRef>
+        </p:style>
+        <p:txBody>
+          <a:bodyPr rtlCol="0" anchor="ctr"/>
+          <a:lstStyle/>
+          <a:p>
+            <a:pPr algn="ctr"/>
+          </a:p>
+        </p:txBody>
+      </p:sp>
+      <p:sp>
+        <p:nvSpPr>
+          <p:cNvPr id="15" name="TextBox 14"/>
+          <p:cNvSpPr txBox="1"/>
+          <p:nvPr/>
+        </p:nvSpPr>
+        <p:spPr>
+          <a:xfrm>
+            <a:off x="8458200" y="3566160"/>
+            <a:ext cx="457200" cy="365760"/>
+          </a:xfrm>
+          <a:prstGeom prst="rect">
+            <a:avLst/>
+          </a:prstGeom>
+          <a:noFill/>
+        </p:spPr>
+        <p:txBody>
+          <a:bodyPr wrap="square">
+            <a:spAutoFit/>
+          </a:bodyPr>
+          <a:lstStyle/>
+          <a:p>
+            <a:pPr algn="l">
+              <a:defRPr sz="2000" b="0">
+                <a:solidFill>
+                  <a:srgbClr val="F0F0F5"/>
+                </a:solidFill>
+                <a:latin typeface="Calibri"/>
+              </a:defRPr>
+            </a:pPr>
+            <a:r>
+              <a:t>🤝</a:t>
+            </a:r>
+          </a:p>
+        </p:txBody>
+      </p:sp>
+      <p:sp>
+        <p:nvSpPr>
+          <p:cNvPr id="16" name="TextBox 15"/>
+          <p:cNvSpPr txBox="1"/>
+          <p:nvPr/>
+        </p:nvSpPr>
+        <p:spPr>
+          <a:xfrm>
+            <a:off x="8458200" y="3886200"/>
+            <a:ext cx="2743200" cy="320040"/>
+          </a:xfrm>
+          <a:prstGeom prst="rect">
+            <a:avLst/>
+          </a:prstGeom>
+          <a:noFill/>
+        </p:spPr>
+        <p:txBody>
+          <a:bodyPr wrap="square">
+            <a:spAutoFit/>
+          </a:bodyPr>
+          <a:lstStyle/>
+          <a:p>
+            <a:pPr algn="l">
+              <a:defRPr sz="1300" b="1">
+                <a:solidFill>
+                  <a:srgbClr val="F0F0F5"/>
+                </a:solidFill>
+                <a:latin typeface="Calibri"/>
+              </a:defRPr>
+            </a:pPr>
+            <a:r>
+              <a:t>Engineering Partnership</a:t>
+            </a:r>
+          </a:p>
+        </p:txBody>
+      </p:sp>
+      <p:sp>
+        <p:nvSpPr>
+          <p:cNvPr id="17" name="TextBox 16"/>
+          <p:cNvSpPr txBox="1"/>
+          <p:nvPr/>
+        </p:nvSpPr>
+        <p:spPr>
+          <a:xfrm>
+            <a:off x="8458200" y="4206240"/>
+            <a:ext cx="2743200" cy="1097280"/>
+          </a:xfrm>
+          <a:prstGeom prst="rect">
+            <a:avLst/>
+          </a:prstGeom>
+          <a:noFill/>
+        </p:spPr>
+        <p:txBody>
+          <a:bodyPr wrap="square">
+            <a:spAutoFit/>
+          </a:bodyPr>
+          <a:lstStyle/>
+          <a:p>
+            <a:pPr algn="l">
+              <a:defRPr sz="1000" b="0">
+                <a:solidFill>
+                  <a:srgbClr val="9CA3AF"/>
+                </a:solidFill>
+                <a:latin typeface="Calibri"/>
+              </a:defRPr>
+            </a:pPr>
+            <a:r>
+              <a:t>We don't just hand over a tool. Our team works hand-in-hand with your engineers to align the rollout with your existing workflows.</a:t>
+            </a:r>
+          </a:p>
+        </p:txBody>
+      </p:sp>
+      <p:sp>
+        <p:nvSpPr>
+          <p:cNvPr id="18" name="TextBox 17"/>
+          <p:cNvSpPr txBox="1"/>
+          <p:nvPr/>
+        </p:nvSpPr>
+        <p:spPr>
+          <a:xfrm>
+            <a:off x="548640" y="6309360"/>
+            <a:ext cx="2743200" cy="365760"/>
+          </a:xfrm>
+          <a:prstGeom prst="rect">
+            <a:avLst/>
+          </a:prstGeom>
+          <a:noFill/>
+        </p:spPr>
+        <p:txBody>
+          <a:bodyPr wrap="square">
+            <a:spAutoFit/>
+          </a:bodyPr>
+          <a:lstStyle/>
+          <a:p>
+            <a:pPr algn="l">
+              <a:defRPr sz="700" b="1">
+                <a:solidFill>
+                  <a:srgbClr val="6B7280"/>
+                </a:solidFill>
+                <a:latin typeface="Calibri"/>
+              </a:defRPr>
+            </a:pPr>
+            <a:r>
+              <a:t>AUTONOMOUS SECURITY REMEDIATION</a:t>
+            </a:r>
+          </a:p>
+        </p:txBody>
+      </p:sp>
+      <p:sp>
+        <p:nvSpPr>
+          <p:cNvPr id="19" name="TextBox 18"/>
+          <p:cNvSpPr txBox="1"/>
+          <p:nvPr/>
+        </p:nvSpPr>
+        <p:spPr>
+          <a:xfrm>
+            <a:off x="10820095" y="6309360"/>
+            <a:ext cx="1097280" cy="365760"/>
+          </a:xfrm>
+          <a:prstGeom prst="rect">
+            <a:avLst/>
+          </a:prstGeom>
+          <a:noFill/>
+        </p:spPr>
+        <p:txBody>
+          <a:bodyPr wrap="square">
+            <a:spAutoFit/>
+          </a:bodyPr>
+          <a:lstStyle/>
+          <a:p>
+            <a:pPr algn="r">
+              <a:defRPr sz="900" b="0">
+                <a:solidFill>
+                  <a:srgbClr val="6B7280"/>
+                </a:solidFill>
+                <a:latin typeface="Calibri"/>
+              </a:defRPr>
+            </a:pPr>
+            <a:r>
+              <a:t>08 / 09</a:t>
             </a:r>
           </a:p>
         </p:txBody>

</xml_diff>

<commit_message>
feat: add Slack notifications bubble to POC-to-Production slide
Add a fourth card (Slack Notifications) to the roadmap slide in both the
HTML deck and the PPTX, switching the grid from 3 to 4 columns.

Co-Authored-By: Devin AI <158243242+devin-ai-integration[bot]@users.noreply.github.com>
</commit_message>
<xml_diff>
--- a/presentation.pptx
+++ b/presentation.pptx
@@ -9140,22 +9140,22 @@
         </p:nvSpPr>
         <p:spPr>
           <a:xfrm>
-            <a:off x="0" y="1828800"/>
-            <a:ext cx="12191695" cy="1371600"/>
-          </a:xfrm>
-          <a:prstGeom prst="rect">
-            <a:avLst/>
-          </a:prstGeom>
-          <a:noFill/>
-        </p:spPr>
-        <p:txBody>
-          <a:bodyPr wrap="square">
-            <a:spAutoFit/>
-          </a:bodyPr>
-          <a:lstStyle/>
-          <a:p>
-            <a:pPr algn="ctr">
-              <a:defRPr sz="7200" b="1">
+            <a:off x="1097280" y="731520"/>
+            <a:ext cx="3657600" cy="320040"/>
+          </a:xfrm>
+          <a:prstGeom prst="rect">
+            <a:avLst/>
+          </a:prstGeom>
+          <a:noFill/>
+        </p:spPr>
+        <p:txBody>
+          <a:bodyPr wrap="square">
+            <a:spAutoFit/>
+          </a:bodyPr>
+          <a:lstStyle/>
+          <a:p>
+            <a:pPr algn="l">
+              <a:defRPr sz="900" b="1">
                 <a:solidFill>
                   <a:srgbClr val="818CF8"/>
                 </a:solidFill>
@@ -9163,7 +9163,7 @@
               </a:defRPr>
             </a:pPr>
             <a:r>
-              <a:t>Q&amp;A</a:t>
+              <a:t>THE ROADMAP</a:t>
             </a:r>
           </a:p>
         </p:txBody>
@@ -9176,22 +9176,101 @@
         </p:nvSpPr>
         <p:spPr>
           <a:xfrm>
-            <a:off x="2286000" y="3474720"/>
-            <a:ext cx="7619695" cy="548640"/>
-          </a:xfrm>
-          <a:prstGeom prst="rect">
-            <a:avLst/>
-          </a:prstGeom>
-          <a:noFill/>
-        </p:spPr>
-        <p:txBody>
-          <a:bodyPr wrap="square">
-            <a:spAutoFit/>
-          </a:bodyPr>
-          <a:lstStyle/>
-          <a:p>
-            <a:pPr algn="ctr">
-              <a:defRPr sz="1600" b="0">
+            <a:off x="1097280" y="1097280"/>
+            <a:ext cx="7315200" cy="640080"/>
+          </a:xfrm>
+          <a:prstGeom prst="rect">
+            <a:avLst/>
+          </a:prstGeom>
+          <a:noFill/>
+        </p:spPr>
+        <p:txBody>
+          <a:bodyPr wrap="square">
+            <a:spAutoFit/>
+          </a:bodyPr>
+          <a:lstStyle/>
+          <a:p>
+            <a:pPr algn="l">
+              <a:defRPr sz="3400" b="1">
+                <a:solidFill>
+                  <a:srgbClr val="F0F0F5"/>
+                </a:solidFill>
+                <a:latin typeface="Calibri"/>
+              </a:defRPr>
+            </a:pPr>
+            <a:r>
+              <a:t>From POC to Production Rollout</a:t>
+            </a:r>
+          </a:p>
+        </p:txBody>
+      </p:sp>
+      <p:sp>
+        <p:nvSpPr>
+          <p:cNvPr id="4" name="Rectangle 3"/>
+          <p:cNvSpPr/>
+          <p:nvPr/>
+        </p:nvSpPr>
+        <p:spPr>
+          <a:xfrm>
+            <a:off x="1097280" y="1783080"/>
+            <a:ext cx="457200" cy="38100"/>
+          </a:xfrm>
+          <a:prstGeom prst="rect">
+            <a:avLst/>
+          </a:prstGeom>
+          <a:solidFill>
+            <a:srgbClr val="6366F1"/>
+          </a:solidFill>
+          <a:ln>
+            <a:noFill/>
+          </a:ln>
+        </p:spPr>
+        <p:style>
+          <a:lnRef idx="1">
+            <a:schemeClr val="accent1"/>
+          </a:lnRef>
+          <a:fillRef idx="3">
+            <a:schemeClr val="accent1"/>
+          </a:fillRef>
+          <a:effectRef idx="2">
+            <a:schemeClr val="accent1"/>
+          </a:effectRef>
+          <a:fontRef idx="minor">
+            <a:schemeClr val="lt1"/>
+          </a:fontRef>
+        </p:style>
+        <p:txBody>
+          <a:bodyPr rtlCol="0" anchor="ctr"/>
+          <a:lstStyle/>
+          <a:p>
+            <a:pPr algn="ctr"/>
+          </a:p>
+        </p:txBody>
+      </p:sp>
+      <p:sp>
+        <p:nvSpPr>
+          <p:cNvPr id="5" name="TextBox 4"/>
+          <p:cNvSpPr txBox="1"/>
+          <p:nvPr/>
+        </p:nvSpPr>
+        <p:spPr>
+          <a:xfrm>
+            <a:off x="1097280" y="2103120"/>
+            <a:ext cx="7772400" cy="822960"/>
+          </a:xfrm>
+          <a:prstGeom prst="rect">
+            <a:avLst/>
+          </a:prstGeom>
+          <a:noFill/>
+        </p:spPr>
+        <p:txBody>
+          <a:bodyPr wrap="square">
+            <a:spAutoFit/>
+          </a:bodyPr>
+          <a:lstStyle/>
+          <a:p>
+            <a:pPr algn="l">
+              <a:defRPr sz="1400" b="0">
                 <a:solidFill>
                   <a:srgbClr val="9CA3AF"/>
                 </a:solidFill>
@@ -9199,54 +9278,473 @@
               </a:defRPr>
             </a:pPr>
             <a:r>
-              <a:t>Let's discuss the architecture, the tradeoffs,</a:t>
-            </a:r>
-            <a:br/>
-            <a:r>
-              <a:t>and what comes next.</a:t>
-            </a:r>
-          </a:p>
-        </p:txBody>
-      </p:sp>
-      <p:sp>
-        <p:nvSpPr>
-          <p:cNvPr id="4" name="TextBox 3"/>
-          <p:cNvSpPr txBox="1"/>
-          <p:nvPr/>
-        </p:nvSpPr>
-        <p:spPr>
-          <a:xfrm>
-            <a:off x="2286000" y="4572000"/>
-            <a:ext cx="7619695" cy="365760"/>
-          </a:xfrm>
-          <a:prstGeom prst="rect">
-            <a:avLst/>
-          </a:prstGeom>
-          <a:noFill/>
-        </p:spPr>
-        <p:txBody>
-          <a:bodyPr wrap="square">
-            <a:spAutoFit/>
-          </a:bodyPr>
-          <a:lstStyle/>
-          <a:p>
-            <a:pPr algn="ctr">
-              <a:defRPr sz="1100" b="0">
-                <a:solidFill>
-                  <a:srgbClr val="6B7280"/>
-                </a:solidFill>
-                <a:latin typeface="Calibri"/>
-              </a:defRPr>
-            </a:pPr>
-            <a:r>
-              <a:t>Torrance Fredell  ·  github.com/torrancefredell/superset-demo</a:t>
-            </a:r>
-          </a:p>
-        </p:txBody>
-      </p:sp>
-      <p:sp>
-        <p:nvSpPr>
-          <p:cNvPr id="5" name="TextBox 4"/>
+              <a:t>Today is a successful proof of concept. Here is how we scale it into an always-on enterprise capability.</a:t>
+            </a:r>
+          </a:p>
+        </p:txBody>
+      </p:sp>
+      <p:sp>
+        <p:nvSpPr>
+          <p:cNvPr id="6" name="Rounded Rectangle 5"/>
+          <p:cNvSpPr/>
+          <p:nvPr/>
+        </p:nvSpPr>
+        <p:spPr>
+          <a:xfrm>
+            <a:off x="1097280" y="3383280"/>
+            <a:ext cx="2377440" cy="2103120"/>
+          </a:xfrm>
+          <a:prstGeom prst="roundRect">
+            <a:avLst/>
+          </a:prstGeom>
+          <a:solidFill>
+            <a:srgbClr val="16161F"/>
+          </a:solidFill>
+          <a:ln w="12700">
+            <a:solidFill>
+              <a:srgbClr val="2A2A35"/>
+            </a:solidFill>
+          </a:ln>
+        </p:spPr>
+        <p:style>
+          <a:lnRef idx="1">
+            <a:schemeClr val="accent1"/>
+          </a:lnRef>
+          <a:fillRef idx="3">
+            <a:schemeClr val="accent1"/>
+          </a:fillRef>
+          <a:effectRef idx="2">
+            <a:schemeClr val="accent1"/>
+          </a:effectRef>
+          <a:fontRef idx="minor">
+            <a:schemeClr val="lt1"/>
+          </a:fontRef>
+        </p:style>
+        <p:txBody>
+          <a:bodyPr rtlCol="0" anchor="ctr"/>
+          <a:lstStyle/>
+          <a:p>
+            <a:pPr algn="ctr"/>
+          </a:p>
+        </p:txBody>
+      </p:sp>
+      <p:sp>
+        <p:nvSpPr>
+          <p:cNvPr id="7" name="TextBox 6"/>
+          <p:cNvSpPr txBox="1"/>
+          <p:nvPr/>
+        </p:nvSpPr>
+        <p:spPr>
+          <a:xfrm>
+            <a:off x="1325880" y="3566160"/>
+            <a:ext cx="457200" cy="365760"/>
+          </a:xfrm>
+          <a:prstGeom prst="rect">
+            <a:avLst/>
+          </a:prstGeom>
+          <a:noFill/>
+        </p:spPr>
+        <p:txBody>
+          <a:bodyPr wrap="square">
+            <a:spAutoFit/>
+          </a:bodyPr>
+          <a:lstStyle/>
+          <a:p>
+            <a:pPr algn="l">
+              <a:defRPr sz="2000" b="0">
+                <a:solidFill>
+                  <a:srgbClr val="F0F0F5"/>
+                </a:solidFill>
+                <a:latin typeface="Calibri"/>
+              </a:defRPr>
+            </a:pPr>
+            <a:r>
+              <a:t>📈</a:t>
+            </a:r>
+          </a:p>
+        </p:txBody>
+      </p:sp>
+      <p:sp>
+        <p:nvSpPr>
+          <p:cNvPr id="8" name="TextBox 7"/>
+          <p:cNvSpPr txBox="1"/>
+          <p:nvPr/>
+        </p:nvSpPr>
+        <p:spPr>
+          <a:xfrm>
+            <a:off x="1325880" y="3886200"/>
+            <a:ext cx="1920240" cy="320040"/>
+          </a:xfrm>
+          <a:prstGeom prst="rect">
+            <a:avLst/>
+          </a:prstGeom>
+          <a:noFill/>
+        </p:spPr>
+        <p:txBody>
+          <a:bodyPr wrap="square">
+            <a:spAutoFit/>
+          </a:bodyPr>
+          <a:lstStyle/>
+          <a:p>
+            <a:pPr algn="l">
+              <a:defRPr sz="1300" b="1">
+                <a:solidFill>
+                  <a:srgbClr val="F0F0F5"/>
+                </a:solidFill>
+                <a:latin typeface="Calibri"/>
+              </a:defRPr>
+            </a:pPr>
+            <a:r>
+              <a:t>Sweep &amp; Scale</a:t>
+            </a:r>
+          </a:p>
+        </p:txBody>
+      </p:sp>
+      <p:sp>
+        <p:nvSpPr>
+          <p:cNvPr id="9" name="TextBox 8"/>
+          <p:cNvSpPr txBox="1"/>
+          <p:nvPr/>
+        </p:nvSpPr>
+        <p:spPr>
+          <a:xfrm>
+            <a:off x="1325880" y="4206240"/>
+            <a:ext cx="1920240" cy="1097280"/>
+          </a:xfrm>
+          <a:prstGeom prst="rect">
+            <a:avLst/>
+          </a:prstGeom>
+          <a:noFill/>
+        </p:spPr>
+        <p:txBody>
+          <a:bodyPr wrap="square">
+            <a:spAutoFit/>
+          </a:bodyPr>
+          <a:lstStyle/>
+          <a:p>
+            <a:pPr algn="l">
+              <a:defRPr sz="1000" b="0">
+                <a:solidFill>
+                  <a:srgbClr val="9CA3AF"/>
+                </a:solidFill>
+                <a:latin typeface="Calibri"/>
+              </a:defRPr>
+            </a:pPr>
+            <a:r>
+              <a:t>Connect Devin to more repositories and trigger automated backlog sweeps — continuously clearing existing security debt in the background.</a:t>
+            </a:r>
+          </a:p>
+        </p:txBody>
+      </p:sp>
+      <p:sp>
+        <p:nvSpPr>
+          <p:cNvPr id="10" name="Rounded Rectangle 9"/>
+          <p:cNvSpPr/>
+          <p:nvPr/>
+        </p:nvSpPr>
+        <p:spPr>
+          <a:xfrm>
+            <a:off x="3749040" y="3383280"/>
+            <a:ext cx="2377440" cy="2103120"/>
+          </a:xfrm>
+          <a:prstGeom prst="roundRect">
+            <a:avLst/>
+          </a:prstGeom>
+          <a:solidFill>
+            <a:srgbClr val="16161F"/>
+          </a:solidFill>
+          <a:ln w="12700">
+            <a:solidFill>
+              <a:srgbClr val="2A2A35"/>
+            </a:solidFill>
+          </a:ln>
+        </p:spPr>
+        <p:style>
+          <a:lnRef idx="1">
+            <a:schemeClr val="accent1"/>
+          </a:lnRef>
+          <a:fillRef idx="3">
+            <a:schemeClr val="accent1"/>
+          </a:fillRef>
+          <a:effectRef idx="2">
+            <a:schemeClr val="accent1"/>
+          </a:effectRef>
+          <a:fontRef idx="minor">
+            <a:schemeClr val="lt1"/>
+          </a:fontRef>
+        </p:style>
+        <p:txBody>
+          <a:bodyPr rtlCol="0" anchor="ctr"/>
+          <a:lstStyle/>
+          <a:p>
+            <a:pPr algn="ctr"/>
+          </a:p>
+        </p:txBody>
+      </p:sp>
+      <p:sp>
+        <p:nvSpPr>
+          <p:cNvPr id="11" name="TextBox 10"/>
+          <p:cNvSpPr txBox="1"/>
+          <p:nvPr/>
+        </p:nvSpPr>
+        <p:spPr>
+          <a:xfrm>
+            <a:off x="3977640" y="3566160"/>
+            <a:ext cx="457200" cy="365760"/>
+          </a:xfrm>
+          <a:prstGeom prst="rect">
+            <a:avLst/>
+          </a:prstGeom>
+          <a:noFill/>
+        </p:spPr>
+        <p:txBody>
+          <a:bodyPr wrap="square">
+            <a:spAutoFit/>
+          </a:bodyPr>
+          <a:lstStyle/>
+          <a:p>
+            <a:pPr algn="l">
+              <a:defRPr sz="2000" b="0">
+                <a:solidFill>
+                  <a:srgbClr val="F0F0F5"/>
+                </a:solidFill>
+                <a:latin typeface="Calibri"/>
+              </a:defRPr>
+            </a:pPr>
+            <a:r>
+              <a:t>🛡️</a:t>
+            </a:r>
+          </a:p>
+        </p:txBody>
+      </p:sp>
+      <p:sp>
+        <p:nvSpPr>
+          <p:cNvPr id="12" name="TextBox 11"/>
+          <p:cNvSpPr txBox="1"/>
+          <p:nvPr/>
+        </p:nvSpPr>
+        <p:spPr>
+          <a:xfrm>
+            <a:off x="3977640" y="3886200"/>
+            <a:ext cx="1920240" cy="320040"/>
+          </a:xfrm>
+          <a:prstGeom prst="rect">
+            <a:avLst/>
+          </a:prstGeom>
+          <a:noFill/>
+        </p:spPr>
+        <p:txBody>
+          <a:bodyPr wrap="square">
+            <a:spAutoFit/>
+          </a:bodyPr>
+          <a:lstStyle/>
+          <a:p>
+            <a:pPr algn="l">
+              <a:defRPr sz="1300" b="1">
+                <a:solidFill>
+                  <a:srgbClr val="F0F0F5"/>
+                </a:solidFill>
+                <a:latin typeface="Calibri"/>
+              </a:defRPr>
+            </a:pPr>
+            <a:r>
+              <a:t>Multi-Agent Guardrails</a:t>
+            </a:r>
+          </a:p>
+        </p:txBody>
+      </p:sp>
+      <p:sp>
+        <p:nvSpPr>
+          <p:cNvPr id="13" name="TextBox 12"/>
+          <p:cNvSpPr txBox="1"/>
+          <p:nvPr/>
+        </p:nvSpPr>
+        <p:spPr>
+          <a:xfrm>
+            <a:off x="3977640" y="4206240"/>
+            <a:ext cx="1920240" cy="1097280"/>
+          </a:xfrm>
+          <a:prstGeom prst="rect">
+            <a:avLst/>
+          </a:prstGeom>
+          <a:noFill/>
+        </p:spPr>
+        <p:txBody>
+          <a:bodyPr wrap="square">
+            <a:spAutoFit/>
+          </a:bodyPr>
+          <a:lstStyle/>
+          <a:p>
+            <a:pPr algn="l">
+              <a:defRPr sz="1000" b="0">
+                <a:solidFill>
+                  <a:srgbClr val="9CA3AF"/>
+                </a:solidFill>
+                <a:latin typeface="Calibri"/>
+              </a:defRPr>
+            </a:pPr>
+            <a:r>
+              <a:t>A second Devin instance acts as an automated peer-reviewer, auditing every patch before a human engineer ever sees it.</a:t>
+            </a:r>
+          </a:p>
+        </p:txBody>
+      </p:sp>
+      <p:sp>
+        <p:nvSpPr>
+          <p:cNvPr id="14" name="Rounded Rectangle 13"/>
+          <p:cNvSpPr/>
+          <p:nvPr/>
+        </p:nvSpPr>
+        <p:spPr>
+          <a:xfrm>
+            <a:off x="6400800" y="3383280"/>
+            <a:ext cx="2377440" cy="2103120"/>
+          </a:xfrm>
+          <a:prstGeom prst="roundRect">
+            <a:avLst/>
+          </a:prstGeom>
+          <a:solidFill>
+            <a:srgbClr val="16161F"/>
+          </a:solidFill>
+          <a:ln w="12700">
+            <a:solidFill>
+              <a:srgbClr val="2A2A35"/>
+            </a:solidFill>
+          </a:ln>
+        </p:spPr>
+        <p:style>
+          <a:lnRef idx="1">
+            <a:schemeClr val="accent1"/>
+          </a:lnRef>
+          <a:fillRef idx="3">
+            <a:schemeClr val="accent1"/>
+          </a:fillRef>
+          <a:effectRef idx="2">
+            <a:schemeClr val="accent1"/>
+          </a:effectRef>
+          <a:fontRef idx="minor">
+            <a:schemeClr val="lt1"/>
+          </a:fontRef>
+        </p:style>
+        <p:txBody>
+          <a:bodyPr rtlCol="0" anchor="ctr"/>
+          <a:lstStyle/>
+          <a:p>
+            <a:pPr algn="ctr"/>
+          </a:p>
+        </p:txBody>
+      </p:sp>
+      <p:sp>
+        <p:nvSpPr>
+          <p:cNvPr id="15" name="TextBox 14"/>
+          <p:cNvSpPr txBox="1"/>
+          <p:nvPr/>
+        </p:nvSpPr>
+        <p:spPr>
+          <a:xfrm>
+            <a:off x="6629400" y="3566160"/>
+            <a:ext cx="457200" cy="365760"/>
+          </a:xfrm>
+          <a:prstGeom prst="rect">
+            <a:avLst/>
+          </a:prstGeom>
+          <a:noFill/>
+        </p:spPr>
+        <p:txBody>
+          <a:bodyPr wrap="square">
+            <a:spAutoFit/>
+          </a:bodyPr>
+          <a:lstStyle/>
+          <a:p>
+            <a:pPr algn="l">
+              <a:defRPr sz="2000" b="0">
+                <a:solidFill>
+                  <a:srgbClr val="F0F0F5"/>
+                </a:solidFill>
+                <a:latin typeface="Calibri"/>
+              </a:defRPr>
+            </a:pPr>
+            <a:r>
+              <a:t>🤝</a:t>
+            </a:r>
+          </a:p>
+        </p:txBody>
+      </p:sp>
+      <p:sp>
+        <p:nvSpPr>
+          <p:cNvPr id="16" name="TextBox 15"/>
+          <p:cNvSpPr txBox="1"/>
+          <p:nvPr/>
+        </p:nvSpPr>
+        <p:spPr>
+          <a:xfrm>
+            <a:off x="6629400" y="3886200"/>
+            <a:ext cx="1920240" cy="320040"/>
+          </a:xfrm>
+          <a:prstGeom prst="rect">
+            <a:avLst/>
+          </a:prstGeom>
+          <a:noFill/>
+        </p:spPr>
+        <p:txBody>
+          <a:bodyPr wrap="square">
+            <a:spAutoFit/>
+          </a:bodyPr>
+          <a:lstStyle/>
+          <a:p>
+            <a:pPr algn="l">
+              <a:defRPr sz="1300" b="1">
+                <a:solidFill>
+                  <a:srgbClr val="F0F0F5"/>
+                </a:solidFill>
+                <a:latin typeface="Calibri"/>
+              </a:defRPr>
+            </a:pPr>
+            <a:r>
+              <a:t>Engineering Partnership</a:t>
+            </a:r>
+          </a:p>
+        </p:txBody>
+      </p:sp>
+      <p:sp>
+        <p:nvSpPr>
+          <p:cNvPr id="17" name="TextBox 16"/>
+          <p:cNvSpPr txBox="1"/>
+          <p:nvPr/>
+        </p:nvSpPr>
+        <p:spPr>
+          <a:xfrm>
+            <a:off x="6629400" y="4206240"/>
+            <a:ext cx="1920240" cy="1097280"/>
+          </a:xfrm>
+          <a:prstGeom prst="rect">
+            <a:avLst/>
+          </a:prstGeom>
+          <a:noFill/>
+        </p:spPr>
+        <p:txBody>
+          <a:bodyPr wrap="square">
+            <a:spAutoFit/>
+          </a:bodyPr>
+          <a:lstStyle/>
+          <a:p>
+            <a:pPr algn="l">
+              <a:defRPr sz="1000" b="0">
+                <a:solidFill>
+                  <a:srgbClr val="9CA3AF"/>
+                </a:solidFill>
+                <a:latin typeface="Calibri"/>
+              </a:defRPr>
+            </a:pPr>
+            <a:r>
+              <a:t>We don't just hand over a tool. Our team works hand-in-hand with your engineers to align the rollout with your existing workflows.</a:t>
+            </a:r>
+          </a:p>
+        </p:txBody>
+      </p:sp>
+      <p:sp>
+        <p:nvSpPr>
+          <p:cNvPr id="18" name="TextBox 17"/>
           <p:cNvSpPr txBox="1"/>
           <p:nvPr/>
         </p:nvSpPr>
@@ -9282,7 +9780,7 @@
       </p:sp>
       <p:sp>
         <p:nvSpPr>
-          <p:cNvPr id="6" name="TextBox 5"/>
+          <p:cNvPr id="19" name="TextBox 18"/>
           <p:cNvSpPr txBox="1"/>
           <p:nvPr/>
         </p:nvSpPr>
@@ -9311,7 +9809,160 @@
               </a:defRPr>
             </a:pPr>
             <a:r>
-              <a:t>09 / 09</a:t>
+              <a:t>08 / 09</a:t>
+            </a:r>
+          </a:p>
+        </p:txBody>
+      </p:sp>
+      <p:sp>
+        <p:nvSpPr>
+          <p:cNvPr id="14" name="Rounded Rectangle 13"/>
+          <p:cNvSpPr/>
+          <p:nvPr/>
+        </p:nvSpPr>
+        <p:spPr>
+          <a:xfrm>
+            <a:off x="9052560" y="3383280"/>
+            <a:ext cx="2377440" cy="2103120"/>
+          </a:xfrm>
+          <a:prstGeom prst="roundRect">
+            <a:avLst/>
+          </a:prstGeom>
+          <a:solidFill>
+            <a:srgbClr val="16161F"/>
+          </a:solidFill>
+          <a:ln w="12700">
+            <a:solidFill>
+              <a:srgbClr val="2A2A35"/>
+            </a:solidFill>
+          </a:ln>
+        </p:spPr>
+        <p:style>
+          <a:lnRef idx="1">
+            <a:schemeClr val="accent1"/>
+          </a:lnRef>
+          <a:fillRef idx="3">
+            <a:schemeClr val="accent1"/>
+          </a:fillRef>
+          <a:effectRef idx="2">
+            <a:schemeClr val="accent1"/>
+          </a:effectRef>
+          <a:fontRef idx="minor">
+            <a:schemeClr val="lt1"/>
+          </a:fontRef>
+        </p:style>
+        <p:txBody>
+          <a:bodyPr rtlCol="0" anchor="ctr"/>
+          <a:lstStyle/>
+          <a:p>
+            <a:pPr algn="ctr"/>
+          </a:p>
+        </p:txBody>
+      </p:sp>
+      <p:sp>
+        <p:nvSpPr>
+          <p:cNvPr id="15" name="TextBox 14"/>
+          <p:cNvSpPr txBox="1"/>
+          <p:nvPr/>
+        </p:nvSpPr>
+        <p:spPr>
+          <a:xfrm>
+            <a:off x="9281160" y="3566160"/>
+            <a:ext cx="457200" cy="365760"/>
+          </a:xfrm>
+          <a:prstGeom prst="rect">
+            <a:avLst/>
+          </a:prstGeom>
+          <a:noFill/>
+        </p:spPr>
+        <p:txBody>
+          <a:bodyPr wrap="square">
+            <a:spAutoFit/>
+          </a:bodyPr>
+          <a:lstStyle/>
+          <a:p>
+            <a:pPr algn="l">
+              <a:defRPr sz="2000" b="0">
+                <a:solidFill>
+                  <a:srgbClr val="F0F0F5"/>
+                </a:solidFill>
+                <a:latin typeface="Calibri"/>
+              </a:defRPr>
+            </a:pPr>
+            <a:r>
+              <a:t>💬</a:t>
+            </a:r>
+          </a:p>
+        </p:txBody>
+      </p:sp>
+      <p:sp>
+        <p:nvSpPr>
+          <p:cNvPr id="16" name="TextBox 15"/>
+          <p:cNvSpPr txBox="1"/>
+          <p:nvPr/>
+        </p:nvSpPr>
+        <p:spPr>
+          <a:xfrm>
+            <a:off x="9281160" y="3886200"/>
+            <a:ext cx="1920240" cy="320040"/>
+          </a:xfrm>
+          <a:prstGeom prst="rect">
+            <a:avLst/>
+          </a:prstGeom>
+          <a:noFill/>
+        </p:spPr>
+        <p:txBody>
+          <a:bodyPr wrap="square">
+            <a:spAutoFit/>
+          </a:bodyPr>
+          <a:lstStyle/>
+          <a:p>
+            <a:pPr algn="l">
+              <a:defRPr sz="1300" b="1">
+                <a:solidFill>
+                  <a:srgbClr val="F0F0F5"/>
+                </a:solidFill>
+                <a:latin typeface="Calibri"/>
+              </a:defRPr>
+            </a:pPr>
+            <a:r>
+              <a:t>Slack Notifications</a:t>
+            </a:r>
+          </a:p>
+        </p:txBody>
+      </p:sp>
+      <p:sp>
+        <p:nvSpPr>
+          <p:cNvPr id="17" name="TextBox 16"/>
+          <p:cNvSpPr txBox="1"/>
+          <p:nvPr/>
+        </p:nvSpPr>
+        <p:spPr>
+          <a:xfrm>
+            <a:off x="9281160" y="4206240"/>
+            <a:ext cx="1920240" cy="1097280"/>
+          </a:xfrm>
+          <a:prstGeom prst="rect">
+            <a:avLst/>
+          </a:prstGeom>
+          <a:noFill/>
+        </p:spPr>
+        <p:txBody>
+          <a:bodyPr wrap="square">
+            <a:spAutoFit/>
+          </a:bodyPr>
+          <a:lstStyle/>
+          <a:p>
+            <a:pPr algn="l">
+              <a:defRPr sz="1000" b="0">
+                <a:solidFill>
+                  <a:srgbClr val="9CA3AF"/>
+                </a:solidFill>
+                <a:latin typeface="Calibri"/>
+              </a:defRPr>
+            </a:pPr>
+            <a:r>
+              <a:t>Wire the pipeline into Slack so the moment Devin opens a PR, your engineering team is pinged instantly — zero dashboard polling.</a:t>
             </a:r>
           </a:p>
         </p:txBody>
@@ -9350,22 +10001,22 @@
         </p:nvSpPr>
         <p:spPr>
           <a:xfrm>
-            <a:off x="1097280" y="731520"/>
-            <a:ext cx="3657600" cy="320040"/>
-          </a:xfrm>
-          <a:prstGeom prst="rect">
-            <a:avLst/>
-          </a:prstGeom>
-          <a:noFill/>
-        </p:spPr>
-        <p:txBody>
-          <a:bodyPr wrap="square">
-            <a:spAutoFit/>
-          </a:bodyPr>
-          <a:lstStyle/>
-          <a:p>
-            <a:pPr algn="l">
-              <a:defRPr sz="900" b="1">
+            <a:off x="0" y="1828800"/>
+            <a:ext cx="12191695" cy="1371600"/>
+          </a:xfrm>
+          <a:prstGeom prst="rect">
+            <a:avLst/>
+          </a:prstGeom>
+          <a:noFill/>
+        </p:spPr>
+        <p:txBody>
+          <a:bodyPr wrap="square">
+            <a:spAutoFit/>
+          </a:bodyPr>
+          <a:lstStyle/>
+          <a:p>
+            <a:pPr algn="ctr">
+              <a:defRPr sz="7200" b="1">
                 <a:solidFill>
                   <a:srgbClr val="818CF8"/>
                 </a:solidFill>
@@ -9373,7 +10024,7 @@
               </a:defRPr>
             </a:pPr>
             <a:r>
-              <a:t>THE ROADMAP</a:t>
+              <a:t>Q&amp;A</a:t>
             </a:r>
           </a:p>
         </p:txBody>
@@ -9386,575 +10037,77 @@
         </p:nvSpPr>
         <p:spPr>
           <a:xfrm>
-            <a:off x="1097280" y="1097280"/>
-            <a:ext cx="7315200" cy="640080"/>
-          </a:xfrm>
-          <a:prstGeom prst="rect">
-            <a:avLst/>
-          </a:prstGeom>
-          <a:noFill/>
-        </p:spPr>
-        <p:txBody>
-          <a:bodyPr wrap="square">
-            <a:spAutoFit/>
-          </a:bodyPr>
-          <a:lstStyle/>
-          <a:p>
-            <a:pPr algn="l">
-              <a:defRPr sz="3400" b="1">
-                <a:solidFill>
-                  <a:srgbClr val="F0F0F5"/>
-                </a:solidFill>
-                <a:latin typeface="Calibri"/>
-              </a:defRPr>
-            </a:pPr>
-            <a:r>
-              <a:t>From POC to Production Rollout</a:t>
-            </a:r>
-          </a:p>
-        </p:txBody>
-      </p:sp>
-      <p:sp>
-        <p:nvSpPr>
-          <p:cNvPr id="4" name="Rectangle 3"/>
-          <p:cNvSpPr/>
-          <p:nvPr/>
-        </p:nvSpPr>
-        <p:spPr>
-          <a:xfrm>
-            <a:off x="1097280" y="1783080"/>
-            <a:ext cx="457200" cy="38100"/>
-          </a:xfrm>
-          <a:prstGeom prst="rect">
-            <a:avLst/>
-          </a:prstGeom>
-          <a:solidFill>
-            <a:srgbClr val="6366F1"/>
-          </a:solidFill>
-          <a:ln>
-            <a:noFill/>
-          </a:ln>
-        </p:spPr>
-        <p:style>
-          <a:lnRef idx="1">
-            <a:schemeClr val="accent1"/>
-          </a:lnRef>
-          <a:fillRef idx="3">
-            <a:schemeClr val="accent1"/>
-          </a:fillRef>
-          <a:effectRef idx="2">
-            <a:schemeClr val="accent1"/>
-          </a:effectRef>
-          <a:fontRef idx="minor">
-            <a:schemeClr val="lt1"/>
-          </a:fontRef>
-        </p:style>
-        <p:txBody>
-          <a:bodyPr rtlCol="0" anchor="ctr"/>
-          <a:lstStyle/>
-          <a:p>
-            <a:pPr algn="ctr"/>
+            <a:off x="2286000" y="3474720"/>
+            <a:ext cx="7619695" cy="548640"/>
+          </a:xfrm>
+          <a:prstGeom prst="rect">
+            <a:avLst/>
+          </a:prstGeom>
+          <a:noFill/>
+        </p:spPr>
+        <p:txBody>
+          <a:bodyPr wrap="square">
+            <a:spAutoFit/>
+          </a:bodyPr>
+          <a:lstStyle/>
+          <a:p>
+            <a:pPr algn="ctr">
+              <a:defRPr sz="1600" b="0">
+                <a:solidFill>
+                  <a:srgbClr val="9CA3AF"/>
+                </a:solidFill>
+                <a:latin typeface="Calibri"/>
+              </a:defRPr>
+            </a:pPr>
+            <a:r>
+              <a:t>Let's discuss the architecture, the tradeoffs,</a:t>
+            </a:r>
+            <a:br/>
+            <a:r>
+              <a:t>and what comes next.</a:t>
+            </a:r>
+          </a:p>
+        </p:txBody>
+      </p:sp>
+      <p:sp>
+        <p:nvSpPr>
+          <p:cNvPr id="4" name="TextBox 3"/>
+          <p:cNvSpPr txBox="1"/>
+          <p:nvPr/>
+        </p:nvSpPr>
+        <p:spPr>
+          <a:xfrm>
+            <a:off x="2286000" y="4572000"/>
+            <a:ext cx="7619695" cy="365760"/>
+          </a:xfrm>
+          <a:prstGeom prst="rect">
+            <a:avLst/>
+          </a:prstGeom>
+          <a:noFill/>
+        </p:spPr>
+        <p:txBody>
+          <a:bodyPr wrap="square">
+            <a:spAutoFit/>
+          </a:bodyPr>
+          <a:lstStyle/>
+          <a:p>
+            <a:pPr algn="ctr">
+              <a:defRPr sz="1100" b="0">
+                <a:solidFill>
+                  <a:srgbClr val="6B7280"/>
+                </a:solidFill>
+                <a:latin typeface="Calibri"/>
+              </a:defRPr>
+            </a:pPr>
+            <a:r>
+              <a:t>Torrance Fredell  ·  github.com/torrancefredell/superset-demo</a:t>
+            </a:r>
           </a:p>
         </p:txBody>
       </p:sp>
       <p:sp>
         <p:nvSpPr>
           <p:cNvPr id="5" name="TextBox 4"/>
-          <p:cNvSpPr txBox="1"/>
-          <p:nvPr/>
-        </p:nvSpPr>
-        <p:spPr>
-          <a:xfrm>
-            <a:off x="1097280" y="2103120"/>
-            <a:ext cx="7772400" cy="822960"/>
-          </a:xfrm>
-          <a:prstGeom prst="rect">
-            <a:avLst/>
-          </a:prstGeom>
-          <a:noFill/>
-        </p:spPr>
-        <p:txBody>
-          <a:bodyPr wrap="square">
-            <a:spAutoFit/>
-          </a:bodyPr>
-          <a:lstStyle/>
-          <a:p>
-            <a:pPr algn="l">
-              <a:defRPr sz="1400" b="0">
-                <a:solidFill>
-                  <a:srgbClr val="9CA3AF"/>
-                </a:solidFill>
-                <a:latin typeface="Calibri"/>
-              </a:defRPr>
-            </a:pPr>
-            <a:r>
-              <a:t>Today is a successful proof of concept. Here is how we scale it into an always-on enterprise capability.</a:t>
-            </a:r>
-          </a:p>
-        </p:txBody>
-      </p:sp>
-      <p:sp>
-        <p:nvSpPr>
-          <p:cNvPr id="6" name="Rounded Rectangle 5"/>
-          <p:cNvSpPr/>
-          <p:nvPr/>
-        </p:nvSpPr>
-        <p:spPr>
-          <a:xfrm>
-            <a:off x="1097280" y="3383280"/>
-            <a:ext cx="3200400" cy="2103120"/>
-          </a:xfrm>
-          <a:prstGeom prst="roundRect">
-            <a:avLst/>
-          </a:prstGeom>
-          <a:solidFill>
-            <a:srgbClr val="16161F"/>
-          </a:solidFill>
-          <a:ln w="12700">
-            <a:solidFill>
-              <a:srgbClr val="2A2A35"/>
-            </a:solidFill>
-          </a:ln>
-        </p:spPr>
-        <p:style>
-          <a:lnRef idx="1">
-            <a:schemeClr val="accent1"/>
-          </a:lnRef>
-          <a:fillRef idx="3">
-            <a:schemeClr val="accent1"/>
-          </a:fillRef>
-          <a:effectRef idx="2">
-            <a:schemeClr val="accent1"/>
-          </a:effectRef>
-          <a:fontRef idx="minor">
-            <a:schemeClr val="lt1"/>
-          </a:fontRef>
-        </p:style>
-        <p:txBody>
-          <a:bodyPr rtlCol="0" anchor="ctr"/>
-          <a:lstStyle/>
-          <a:p>
-            <a:pPr algn="ctr"/>
-          </a:p>
-        </p:txBody>
-      </p:sp>
-      <p:sp>
-        <p:nvSpPr>
-          <p:cNvPr id="7" name="TextBox 6"/>
-          <p:cNvSpPr txBox="1"/>
-          <p:nvPr/>
-        </p:nvSpPr>
-        <p:spPr>
-          <a:xfrm>
-            <a:off x="1325880" y="3566160"/>
-            <a:ext cx="457200" cy="365760"/>
-          </a:xfrm>
-          <a:prstGeom prst="rect">
-            <a:avLst/>
-          </a:prstGeom>
-          <a:noFill/>
-        </p:spPr>
-        <p:txBody>
-          <a:bodyPr wrap="square">
-            <a:spAutoFit/>
-          </a:bodyPr>
-          <a:lstStyle/>
-          <a:p>
-            <a:pPr algn="l">
-              <a:defRPr sz="2000" b="0">
-                <a:solidFill>
-                  <a:srgbClr val="F0F0F5"/>
-                </a:solidFill>
-                <a:latin typeface="Calibri"/>
-              </a:defRPr>
-            </a:pPr>
-            <a:r>
-              <a:t>📈</a:t>
-            </a:r>
-          </a:p>
-        </p:txBody>
-      </p:sp>
-      <p:sp>
-        <p:nvSpPr>
-          <p:cNvPr id="8" name="TextBox 7"/>
-          <p:cNvSpPr txBox="1"/>
-          <p:nvPr/>
-        </p:nvSpPr>
-        <p:spPr>
-          <a:xfrm>
-            <a:off x="1325880" y="3886200"/>
-            <a:ext cx="2743200" cy="320040"/>
-          </a:xfrm>
-          <a:prstGeom prst="rect">
-            <a:avLst/>
-          </a:prstGeom>
-          <a:noFill/>
-        </p:spPr>
-        <p:txBody>
-          <a:bodyPr wrap="square">
-            <a:spAutoFit/>
-          </a:bodyPr>
-          <a:lstStyle/>
-          <a:p>
-            <a:pPr algn="l">
-              <a:defRPr sz="1300" b="1">
-                <a:solidFill>
-                  <a:srgbClr val="F0F0F5"/>
-                </a:solidFill>
-                <a:latin typeface="Calibri"/>
-              </a:defRPr>
-            </a:pPr>
-            <a:r>
-              <a:t>Sweep &amp; Scale</a:t>
-            </a:r>
-          </a:p>
-        </p:txBody>
-      </p:sp>
-      <p:sp>
-        <p:nvSpPr>
-          <p:cNvPr id="9" name="TextBox 8"/>
-          <p:cNvSpPr txBox="1"/>
-          <p:nvPr/>
-        </p:nvSpPr>
-        <p:spPr>
-          <a:xfrm>
-            <a:off x="1325880" y="4206240"/>
-            <a:ext cx="2743200" cy="1097280"/>
-          </a:xfrm>
-          <a:prstGeom prst="rect">
-            <a:avLst/>
-          </a:prstGeom>
-          <a:noFill/>
-        </p:spPr>
-        <p:txBody>
-          <a:bodyPr wrap="square">
-            <a:spAutoFit/>
-          </a:bodyPr>
-          <a:lstStyle/>
-          <a:p>
-            <a:pPr algn="l">
-              <a:defRPr sz="1000" b="0">
-                <a:solidFill>
-                  <a:srgbClr val="9CA3AF"/>
-                </a:solidFill>
-                <a:latin typeface="Calibri"/>
-              </a:defRPr>
-            </a:pPr>
-            <a:r>
-              <a:t>Connect Devin to more repositories and trigger automated backlog sweeps — continuously clearing existing security debt in the background.</a:t>
-            </a:r>
-          </a:p>
-        </p:txBody>
-      </p:sp>
-      <p:sp>
-        <p:nvSpPr>
-          <p:cNvPr id="10" name="Rounded Rectangle 9"/>
-          <p:cNvSpPr/>
-          <p:nvPr/>
-        </p:nvSpPr>
-        <p:spPr>
-          <a:xfrm>
-            <a:off x="4663440" y="3383280"/>
-            <a:ext cx="3200400" cy="2103120"/>
-          </a:xfrm>
-          <a:prstGeom prst="roundRect">
-            <a:avLst/>
-          </a:prstGeom>
-          <a:solidFill>
-            <a:srgbClr val="16161F"/>
-          </a:solidFill>
-          <a:ln w="12700">
-            <a:solidFill>
-              <a:srgbClr val="2A2A35"/>
-            </a:solidFill>
-          </a:ln>
-        </p:spPr>
-        <p:style>
-          <a:lnRef idx="1">
-            <a:schemeClr val="accent1"/>
-          </a:lnRef>
-          <a:fillRef idx="3">
-            <a:schemeClr val="accent1"/>
-          </a:fillRef>
-          <a:effectRef idx="2">
-            <a:schemeClr val="accent1"/>
-          </a:effectRef>
-          <a:fontRef idx="minor">
-            <a:schemeClr val="lt1"/>
-          </a:fontRef>
-        </p:style>
-        <p:txBody>
-          <a:bodyPr rtlCol="0" anchor="ctr"/>
-          <a:lstStyle/>
-          <a:p>
-            <a:pPr algn="ctr"/>
-          </a:p>
-        </p:txBody>
-      </p:sp>
-      <p:sp>
-        <p:nvSpPr>
-          <p:cNvPr id="11" name="TextBox 10"/>
-          <p:cNvSpPr txBox="1"/>
-          <p:nvPr/>
-        </p:nvSpPr>
-        <p:spPr>
-          <a:xfrm>
-            <a:off x="4892040" y="3566160"/>
-            <a:ext cx="457200" cy="365760"/>
-          </a:xfrm>
-          <a:prstGeom prst="rect">
-            <a:avLst/>
-          </a:prstGeom>
-          <a:noFill/>
-        </p:spPr>
-        <p:txBody>
-          <a:bodyPr wrap="square">
-            <a:spAutoFit/>
-          </a:bodyPr>
-          <a:lstStyle/>
-          <a:p>
-            <a:pPr algn="l">
-              <a:defRPr sz="2000" b="0">
-                <a:solidFill>
-                  <a:srgbClr val="F0F0F5"/>
-                </a:solidFill>
-                <a:latin typeface="Calibri"/>
-              </a:defRPr>
-            </a:pPr>
-            <a:r>
-              <a:t>🛡️</a:t>
-            </a:r>
-          </a:p>
-        </p:txBody>
-      </p:sp>
-      <p:sp>
-        <p:nvSpPr>
-          <p:cNvPr id="12" name="TextBox 11"/>
-          <p:cNvSpPr txBox="1"/>
-          <p:nvPr/>
-        </p:nvSpPr>
-        <p:spPr>
-          <a:xfrm>
-            <a:off x="4892040" y="3886200"/>
-            <a:ext cx="2743200" cy="320040"/>
-          </a:xfrm>
-          <a:prstGeom prst="rect">
-            <a:avLst/>
-          </a:prstGeom>
-          <a:noFill/>
-        </p:spPr>
-        <p:txBody>
-          <a:bodyPr wrap="square">
-            <a:spAutoFit/>
-          </a:bodyPr>
-          <a:lstStyle/>
-          <a:p>
-            <a:pPr algn="l">
-              <a:defRPr sz="1300" b="1">
-                <a:solidFill>
-                  <a:srgbClr val="F0F0F5"/>
-                </a:solidFill>
-                <a:latin typeface="Calibri"/>
-              </a:defRPr>
-            </a:pPr>
-            <a:r>
-              <a:t>Multi-Agent Guardrails</a:t>
-            </a:r>
-          </a:p>
-        </p:txBody>
-      </p:sp>
-      <p:sp>
-        <p:nvSpPr>
-          <p:cNvPr id="13" name="TextBox 12"/>
-          <p:cNvSpPr txBox="1"/>
-          <p:nvPr/>
-        </p:nvSpPr>
-        <p:spPr>
-          <a:xfrm>
-            <a:off x="4892040" y="4206240"/>
-            <a:ext cx="2743200" cy="1097280"/>
-          </a:xfrm>
-          <a:prstGeom prst="rect">
-            <a:avLst/>
-          </a:prstGeom>
-          <a:noFill/>
-        </p:spPr>
-        <p:txBody>
-          <a:bodyPr wrap="square">
-            <a:spAutoFit/>
-          </a:bodyPr>
-          <a:lstStyle/>
-          <a:p>
-            <a:pPr algn="l">
-              <a:defRPr sz="1000" b="0">
-                <a:solidFill>
-                  <a:srgbClr val="9CA3AF"/>
-                </a:solidFill>
-                <a:latin typeface="Calibri"/>
-              </a:defRPr>
-            </a:pPr>
-            <a:r>
-              <a:t>A second Devin instance acts as an automated peer-reviewer, auditing every patch before a human engineer ever sees it.</a:t>
-            </a:r>
-          </a:p>
-        </p:txBody>
-      </p:sp>
-      <p:sp>
-        <p:nvSpPr>
-          <p:cNvPr id="14" name="Rounded Rectangle 13"/>
-          <p:cNvSpPr/>
-          <p:nvPr/>
-        </p:nvSpPr>
-        <p:spPr>
-          <a:xfrm>
-            <a:off x="8229600" y="3383280"/>
-            <a:ext cx="3200400" cy="2103120"/>
-          </a:xfrm>
-          <a:prstGeom prst="roundRect">
-            <a:avLst/>
-          </a:prstGeom>
-          <a:solidFill>
-            <a:srgbClr val="16161F"/>
-          </a:solidFill>
-          <a:ln w="12700">
-            <a:solidFill>
-              <a:srgbClr val="2A2A35"/>
-            </a:solidFill>
-          </a:ln>
-        </p:spPr>
-        <p:style>
-          <a:lnRef idx="1">
-            <a:schemeClr val="accent1"/>
-          </a:lnRef>
-          <a:fillRef idx="3">
-            <a:schemeClr val="accent1"/>
-          </a:fillRef>
-          <a:effectRef idx="2">
-            <a:schemeClr val="accent1"/>
-          </a:effectRef>
-          <a:fontRef idx="minor">
-            <a:schemeClr val="lt1"/>
-          </a:fontRef>
-        </p:style>
-        <p:txBody>
-          <a:bodyPr rtlCol="0" anchor="ctr"/>
-          <a:lstStyle/>
-          <a:p>
-            <a:pPr algn="ctr"/>
-          </a:p>
-        </p:txBody>
-      </p:sp>
-      <p:sp>
-        <p:nvSpPr>
-          <p:cNvPr id="15" name="TextBox 14"/>
-          <p:cNvSpPr txBox="1"/>
-          <p:nvPr/>
-        </p:nvSpPr>
-        <p:spPr>
-          <a:xfrm>
-            <a:off x="8458200" y="3566160"/>
-            <a:ext cx="457200" cy="365760"/>
-          </a:xfrm>
-          <a:prstGeom prst="rect">
-            <a:avLst/>
-          </a:prstGeom>
-          <a:noFill/>
-        </p:spPr>
-        <p:txBody>
-          <a:bodyPr wrap="square">
-            <a:spAutoFit/>
-          </a:bodyPr>
-          <a:lstStyle/>
-          <a:p>
-            <a:pPr algn="l">
-              <a:defRPr sz="2000" b="0">
-                <a:solidFill>
-                  <a:srgbClr val="F0F0F5"/>
-                </a:solidFill>
-                <a:latin typeface="Calibri"/>
-              </a:defRPr>
-            </a:pPr>
-            <a:r>
-              <a:t>🤝</a:t>
-            </a:r>
-          </a:p>
-        </p:txBody>
-      </p:sp>
-      <p:sp>
-        <p:nvSpPr>
-          <p:cNvPr id="16" name="TextBox 15"/>
-          <p:cNvSpPr txBox="1"/>
-          <p:nvPr/>
-        </p:nvSpPr>
-        <p:spPr>
-          <a:xfrm>
-            <a:off x="8458200" y="3886200"/>
-            <a:ext cx="2743200" cy="320040"/>
-          </a:xfrm>
-          <a:prstGeom prst="rect">
-            <a:avLst/>
-          </a:prstGeom>
-          <a:noFill/>
-        </p:spPr>
-        <p:txBody>
-          <a:bodyPr wrap="square">
-            <a:spAutoFit/>
-          </a:bodyPr>
-          <a:lstStyle/>
-          <a:p>
-            <a:pPr algn="l">
-              <a:defRPr sz="1300" b="1">
-                <a:solidFill>
-                  <a:srgbClr val="F0F0F5"/>
-                </a:solidFill>
-                <a:latin typeface="Calibri"/>
-              </a:defRPr>
-            </a:pPr>
-            <a:r>
-              <a:t>Engineering Partnership</a:t>
-            </a:r>
-          </a:p>
-        </p:txBody>
-      </p:sp>
-      <p:sp>
-        <p:nvSpPr>
-          <p:cNvPr id="17" name="TextBox 16"/>
-          <p:cNvSpPr txBox="1"/>
-          <p:nvPr/>
-        </p:nvSpPr>
-        <p:spPr>
-          <a:xfrm>
-            <a:off x="8458200" y="4206240"/>
-            <a:ext cx="2743200" cy="1097280"/>
-          </a:xfrm>
-          <a:prstGeom prst="rect">
-            <a:avLst/>
-          </a:prstGeom>
-          <a:noFill/>
-        </p:spPr>
-        <p:txBody>
-          <a:bodyPr wrap="square">
-            <a:spAutoFit/>
-          </a:bodyPr>
-          <a:lstStyle/>
-          <a:p>
-            <a:pPr algn="l">
-              <a:defRPr sz="1000" b="0">
-                <a:solidFill>
-                  <a:srgbClr val="9CA3AF"/>
-                </a:solidFill>
-                <a:latin typeface="Calibri"/>
-              </a:defRPr>
-            </a:pPr>
-            <a:r>
-              <a:t>We don't just hand over a tool. Our team works hand-in-hand with your engineers to align the rollout with your existing workflows.</a:t>
-            </a:r>
-          </a:p>
-        </p:txBody>
-      </p:sp>
-      <p:sp>
-        <p:nvSpPr>
-          <p:cNvPr id="18" name="TextBox 17"/>
           <p:cNvSpPr txBox="1"/>
           <p:nvPr/>
         </p:nvSpPr>
@@ -9990,7 +10143,7 @@
       </p:sp>
       <p:sp>
         <p:nvSpPr>
-          <p:cNvPr id="19" name="TextBox 18"/>
+          <p:cNvPr id="6" name="TextBox 5"/>
           <p:cNvSpPr txBox="1"/>
           <p:nvPr/>
         </p:nvSpPr>
@@ -10019,7 +10172,7 @@
               </a:defRPr>
             </a:pPr>
             <a:r>
-              <a:t>08 / 09</a:t>
+              <a:t>09 / 09</a:t>
             </a:r>
           </a:p>
         </p:txBody>

</xml_diff>

<commit_message>
feat: reframe roadmap slide as collaborative pilot path
Retitle to 'The Path to Implementation: A Collaborative Pilot', replace
the four-bubble roadmap with three pillars (Collaborative Selection,
Targeted Proof of Concept, Measured Scale-Up), and add a 'not a handoff'
footer note. Updated in both presentation.html and presentation.pptx.

Co-Authored-By: Devin AI <158243242+devin-ai-integration[bot]@users.noreply.github.com>
</commit_message>
<xml_diff>
--- a/presentation.pptx
+++ b/presentation.pptx
@@ -9199,7 +9199,7 @@
               </a:defRPr>
             </a:pPr>
             <a:r>
-              <a:t>From POC to Production Rollout</a:t>
+              <a:t>The Path to Implementation: A Collaborative Pilot</a:t>
             </a:r>
           </a:p>
         </p:txBody>
@@ -9278,7 +9278,7 @@
               </a:defRPr>
             </a:pPr>
             <a:r>
-              <a:t>Today is a successful proof of concept. Here is how we scale it into an always-on enterprise capability.</a:t>
+              <a:t>Today is a successful proof of concept. Here is how we turn it into production value — together, and grounded in your own ROI.</a:t>
             </a:r>
           </a:p>
         </p:txBody>
@@ -9292,7 +9292,7 @@
         <p:spPr>
           <a:xfrm>
             <a:off x="1097280" y="3383280"/>
-            <a:ext cx="2377440" cy="2103120"/>
+            <a:ext cx="3200400" cy="2103120"/>
           </a:xfrm>
           <a:prstGeom prst="roundRect">
             <a:avLst/>
@@ -9359,7 +9359,7 @@
               </a:defRPr>
             </a:pPr>
             <a:r>
-              <a:t>📈</a:t>
+              <a:t>🤝</a:t>
             </a:r>
           </a:p>
         </p:txBody>
@@ -9373,7 +9373,7 @@
         <p:spPr>
           <a:xfrm>
             <a:off x="1325880" y="3886200"/>
-            <a:ext cx="1920240" cy="320040"/>
+            <a:ext cx="2743200" cy="320040"/>
           </a:xfrm>
           <a:prstGeom prst="rect">
             <a:avLst/>
@@ -9395,7 +9395,7 @@
               </a:defRPr>
             </a:pPr>
             <a:r>
-              <a:t>Sweep &amp; Scale</a:t>
+              <a:t>Collaborative Selection</a:t>
             </a:r>
           </a:p>
         </p:txBody>
@@ -9409,7 +9409,7 @@
         <p:spPr>
           <a:xfrm>
             <a:off x="1325880" y="4206240"/>
-            <a:ext cx="1920240" cy="1097280"/>
+            <a:ext cx="2743200" cy="1097280"/>
           </a:xfrm>
           <a:prstGeom prst="rect">
             <a:avLst/>
@@ -9431,7 +9431,7 @@
               </a:defRPr>
             </a:pPr>
             <a:r>
-              <a:t>Connect Devin to more repositories and trigger automated backlog sweeps — continuously clearing existing security debt in the background.</a:t>
+              <a:t>We sit down with your team to select 3–4 direct use cases and the specific pain points unique to your organization.</a:t>
             </a:r>
           </a:p>
         </p:txBody>
@@ -9444,8 +9444,8 @@
         </p:nvSpPr>
         <p:spPr>
           <a:xfrm>
-            <a:off x="3749040" y="3383280"/>
-            <a:ext cx="2377440" cy="2103120"/>
+            <a:off x="4663440" y="3383280"/>
+            <a:ext cx="3200400" cy="2103120"/>
           </a:xfrm>
           <a:prstGeom prst="roundRect">
             <a:avLst/>
@@ -9489,7 +9489,7 @@
         </p:nvSpPr>
         <p:spPr>
           <a:xfrm>
-            <a:off x="3977640" y="3566160"/>
+            <a:off x="4892040" y="3566160"/>
             <a:ext cx="457200" cy="365760"/>
           </a:xfrm>
           <a:prstGeom prst="rect">
@@ -9512,7 +9512,7 @@
               </a:defRPr>
             </a:pPr>
             <a:r>
-              <a:t>🛡️</a:t>
+              <a:t>🎯</a:t>
             </a:r>
           </a:p>
         </p:txBody>
@@ -9525,8 +9525,8 @@
         </p:nvSpPr>
         <p:spPr>
           <a:xfrm>
-            <a:off x="3977640" y="3886200"/>
-            <a:ext cx="1920240" cy="320040"/>
+            <a:off x="4892040" y="3886200"/>
+            <a:ext cx="2743200" cy="320040"/>
           </a:xfrm>
           <a:prstGeom prst="rect">
             <a:avLst/>
@@ -9548,7 +9548,7 @@
               </a:defRPr>
             </a:pPr>
             <a:r>
-              <a:t>Multi-Agent Guardrails</a:t>
+              <a:t>Targeted Proof of Concept</a:t>
             </a:r>
           </a:p>
         </p:txBody>
@@ -9561,8 +9561,8 @@
         </p:nvSpPr>
         <p:spPr>
           <a:xfrm>
-            <a:off x="3977640" y="4206240"/>
-            <a:ext cx="1920240" cy="1097280"/>
+            <a:off x="4892040" y="4206240"/>
+            <a:ext cx="2743200" cy="1097280"/>
           </a:xfrm>
           <a:prstGeom prst="rect">
             <a:avLst/>
@@ -9584,7 +9584,7 @@
               </a:defRPr>
             </a:pPr>
             <a:r>
-              <a:t>A second Devin instance acts as an automated peer-reviewer, auditing every patch before a human engineer ever sees it.</a:t>
+              <a:t>We run a focused pilot with Devin over several weeks to tackle those exact issues inside your own environment.</a:t>
             </a:r>
           </a:p>
         </p:txBody>
@@ -9597,8 +9597,8 @@
         </p:nvSpPr>
         <p:spPr>
           <a:xfrm>
-            <a:off x="6400800" y="3383280"/>
-            <a:ext cx="2377440" cy="2103120"/>
+            <a:off x="8229600" y="3383280"/>
+            <a:ext cx="3200400" cy="2103120"/>
           </a:xfrm>
           <a:prstGeom prst="roundRect">
             <a:avLst/>
@@ -9642,7 +9642,7 @@
         </p:nvSpPr>
         <p:spPr>
           <a:xfrm>
-            <a:off x="6629400" y="3566160"/>
+            <a:off x="8458200" y="3566160"/>
             <a:ext cx="457200" cy="365760"/>
           </a:xfrm>
           <a:prstGeom prst="rect">
@@ -9665,7 +9665,7 @@
               </a:defRPr>
             </a:pPr>
             <a:r>
-              <a:t>🤝</a:t>
+              <a:t>📈</a:t>
             </a:r>
           </a:p>
         </p:txBody>
@@ -9678,8 +9678,8 @@
         </p:nvSpPr>
         <p:spPr>
           <a:xfrm>
-            <a:off x="6629400" y="3886200"/>
-            <a:ext cx="1920240" cy="320040"/>
+            <a:off x="8458200" y="3886200"/>
+            <a:ext cx="2743200" cy="320040"/>
           </a:xfrm>
           <a:prstGeom prst="rect">
             <a:avLst/>
@@ -9701,7 +9701,7 @@
               </a:defRPr>
             </a:pPr>
             <a:r>
-              <a:t>Engineering Partnership</a:t>
+              <a:t>Measured Scale-Up</a:t>
             </a:r>
           </a:p>
         </p:txBody>
@@ -9714,8 +9714,8 @@
         </p:nvSpPr>
         <p:spPr>
           <a:xfrm>
-            <a:off x="6629400" y="4206240"/>
-            <a:ext cx="1920240" cy="1097280"/>
+            <a:off x="8458200" y="4206240"/>
+            <a:ext cx="2743200" cy="1097280"/>
           </a:xfrm>
           <a:prstGeom prst="rect">
             <a:avLst/>
@@ -9737,7 +9737,7 @@
               </a:defRPr>
             </a:pPr>
             <a:r>
-              <a:t>We don't just hand over a tool. Our team works hand-in-hand with your engineers to align the rollout with your existing workflows.</a:t>
+              <a:t>We evaluate concrete ROI results and use those findings to confidently roll Devin out to more developers and broader use cases.</a:t>
             </a:r>
           </a:p>
         </p:txBody>
@@ -9816,153 +9816,33 @@
       </p:sp>
       <p:sp>
         <p:nvSpPr>
-          <p:cNvPr id="14" name="Rounded Rectangle 13"/>
-          <p:cNvSpPr/>
-          <p:nvPr/>
-        </p:nvSpPr>
-        <p:spPr>
-          <a:xfrm>
-            <a:off x="9052560" y="3383280"/>
-            <a:ext cx="2377440" cy="2103120"/>
-          </a:xfrm>
-          <a:prstGeom prst="roundRect">
-            <a:avLst/>
-          </a:prstGeom>
-          <a:solidFill>
-            <a:srgbClr val="16161F"/>
-          </a:solidFill>
-          <a:ln w="12700">
-            <a:solidFill>
-              <a:srgbClr val="2A2A35"/>
-            </a:solidFill>
-          </a:ln>
-        </p:spPr>
-        <p:style>
-          <a:lnRef idx="1">
-            <a:schemeClr val="accent1"/>
-          </a:lnRef>
-          <a:fillRef idx="3">
-            <a:schemeClr val="accent1"/>
-          </a:fillRef>
-          <a:effectRef idx="2">
-            <a:schemeClr val="accent1"/>
-          </a:effectRef>
-          <a:fontRef idx="minor">
-            <a:schemeClr val="lt1"/>
-          </a:fontRef>
-        </p:style>
-        <p:txBody>
-          <a:bodyPr rtlCol="0" anchor="ctr"/>
-          <a:lstStyle/>
-          <a:p>
-            <a:pPr algn="ctr"/>
-          </a:p>
-        </p:txBody>
-      </p:sp>
-      <p:sp>
-        <p:nvSpPr>
-          <p:cNvPr id="15" name="TextBox 14"/>
-          <p:cNvSpPr txBox="1"/>
-          <p:nvPr/>
-        </p:nvSpPr>
-        <p:spPr>
-          <a:xfrm>
-            <a:off x="9281160" y="3566160"/>
-            <a:ext cx="457200" cy="365760"/>
-          </a:xfrm>
-          <a:prstGeom prst="rect">
-            <a:avLst/>
-          </a:prstGeom>
-          <a:noFill/>
-        </p:spPr>
-        <p:txBody>
-          <a:bodyPr wrap="square">
-            <a:spAutoFit/>
-          </a:bodyPr>
-          <a:lstStyle/>
-          <a:p>
-            <a:pPr algn="l">
-              <a:defRPr sz="2000" b="0">
-                <a:solidFill>
-                  <a:srgbClr val="F0F0F5"/>
-                </a:solidFill>
-                <a:latin typeface="Calibri"/>
-              </a:defRPr>
-            </a:pPr>
-            <a:r>
-              <a:t>💬</a:t>
-            </a:r>
-          </a:p>
-        </p:txBody>
-      </p:sp>
-      <p:sp>
-        <p:nvSpPr>
-          <p:cNvPr id="16" name="TextBox 15"/>
-          <p:cNvSpPr txBox="1"/>
-          <p:nvPr/>
-        </p:nvSpPr>
-        <p:spPr>
-          <a:xfrm>
-            <a:off x="9281160" y="3886200"/>
-            <a:ext cx="1920240" cy="320040"/>
-          </a:xfrm>
-          <a:prstGeom prst="rect">
-            <a:avLst/>
-          </a:prstGeom>
-          <a:noFill/>
-        </p:spPr>
-        <p:txBody>
-          <a:bodyPr wrap="square">
-            <a:spAutoFit/>
-          </a:bodyPr>
-          <a:lstStyle/>
-          <a:p>
-            <a:pPr algn="l">
-              <a:defRPr sz="1300" b="1">
-                <a:solidFill>
-                  <a:srgbClr val="F0F0F5"/>
-                </a:solidFill>
-                <a:latin typeface="Calibri"/>
-              </a:defRPr>
-            </a:pPr>
-            <a:r>
-              <a:t>Slack Notifications</a:t>
-            </a:r>
-          </a:p>
-        </p:txBody>
-      </p:sp>
-      <p:sp>
-        <p:nvSpPr>
-          <p:cNvPr id="17" name="TextBox 16"/>
-          <p:cNvSpPr txBox="1"/>
-          <p:nvPr/>
-        </p:nvSpPr>
-        <p:spPr>
-          <a:xfrm>
-            <a:off x="9281160" y="4206240"/>
-            <a:ext cx="1920240" cy="1097280"/>
-          </a:xfrm>
-          <a:prstGeom prst="rect">
-            <a:avLst/>
-          </a:prstGeom>
-          <a:noFill/>
-        </p:spPr>
-        <p:txBody>
-          <a:bodyPr wrap="square">
-            <a:spAutoFit/>
-          </a:bodyPr>
-          <a:lstStyle/>
-          <a:p>
-            <a:pPr algn="l">
-              <a:defRPr sz="1000" b="0">
+          <p:cNvPr id="20" name="TextBox 19"/>
+          <p:cNvSpPr txBox="1"/>
+          <p:nvPr/>
+        </p:nvSpPr>
+        <p:spPr>
+          <a:xfrm>
+            <a:off x="1097280" y="5700000"/>
+            <a:ext cx="10000000" cy="457200"/>
+          </a:xfrm>
+          <a:prstGeom prst="rect">
+            <a:avLst/>
+          </a:prstGeom>
+          <a:noFill/>
+        </p:spPr>
+        <p:txBody>
+          <a:bodyPr wrap="square">
+            <a:spAutoFit/>
+          </a:bodyPr>
+          <a:lstStyle/>
+          <a:p>
+            <a:r>
+              <a:rPr sz="1300" i="1">
                 <a:solidFill>
                   <a:srgbClr val="9CA3AF"/>
                 </a:solidFill>
-                <a:latin typeface="Calibri"/>
-              </a:defRPr>
-            </a:pPr>
-            <a:r>
-              <a:t>Wire the pipeline into Slack so the moment Devin opens a PR, your engineering team is pinged instantly — zero dashboard polling.</a:t>
+              </a:rPr>
+              <a:t>This is not a handoff — our team works hand-in-hand with your engineers to ensure seamless workflow integration.</a:t>
             </a:r>
           </a:p>
         </p:txBody>

</xml_diff>